<commit_message>
Sync docs and decks with implementation: 8-slide narrative, fallback model, 145 tests, docs folder tidy
</commit_message>
<xml_diff>
--- a/docs/presentation/pr-news-monitor.pptx
+++ b/docs/presentation/pr-news-monitor.pptx
@@ -9,11 +9,13 @@
   </p:notesMasterIdLst>
   <p:sldIdLst>
     <p:sldId xmlns:r="http://schemas.openxmlformats.org/officeDocument/2006/relationships" id="256" r:id="R7fdf07ae20ee422c"/>
+    <p:sldId xmlns:ns0="http://schemas.openxmlformats.org/officeDocument/2006/relationships" id="262" ns0:id="rId12"/>
     <p:sldId xmlns:r="http://schemas.openxmlformats.org/officeDocument/2006/relationships" id="257" r:id="Rdceabca2300647d3"/>
-    <p:sldId xmlns:r="http://schemas.openxmlformats.org/officeDocument/2006/relationships" id="258" r:id="Rb2a73ad782d94341"/>
+    <p:sldId xmlns:ns0="http://schemas.openxmlformats.org/officeDocument/2006/relationships" id="263" ns0:id="rId13"/>
     <p:sldId xmlns:r="http://schemas.openxmlformats.org/officeDocument/2006/relationships" id="259" r:id="R77a2c634db264323"/>
     <p:sldId xmlns:r="http://schemas.openxmlformats.org/officeDocument/2006/relationships" id="260" r:id="R957d2fb81b844b85"/>
     <p:sldId xmlns:r="http://schemas.openxmlformats.org/officeDocument/2006/relationships" id="261" r:id="Rbd871e95533f44cc"/>
+    <p:sldId xmlns:ns0="http://schemas.openxmlformats.org/officeDocument/2006/relationships" id="264" ns0:id="rId14"/>
   </p:sldIdLst>
   <p:sldSz cx="12192000" cy="6858000"/>
   <p:notesSz cx="6858000" cy="9144000"/>
@@ -447,27 +449,13 @@
           <a:lstStyle xmlns:a="http://schemas.openxmlformats.org/drawingml/2006/main"/>
           <a:p xmlns:a="http://schemas.openxmlformats.org/drawingml/2006/main">
             <a:r>
-              <a:t>0:00–0:35</a:t>
-            </a:r>
-          </a:p>
+              <a:t>0:00-0:30</a:t>
+            </a:r>
+          </a:p>
+          <a:p xmlns:a="http://schemas.openxmlformats.org/drawingml/2006/main"/>
           <a:p xmlns:a="http://schemas.openxmlformats.org/drawingml/2006/main">
             <a:r>
-              <a:t/>
-            </a:r>
-          </a:p>
-          <a:p xmlns:a="http://schemas.openxmlformats.org/drawingml/2006/main">
-            <a:r>
               <a:t>I built this for a PR team that needs to follow its company and competitors without reading the same story repeatedly. The demo tracks Equinix and Digital Realty, and the names are configurable in YAML. It shows grouped coverage with a short description and links to the original articles. I will show one story in the dashboard, then explain the main decisions and where I would improve it.</a:t>
-            </a:r>
-          </a:p>
-          <a:p xmlns:a="http://schemas.openxmlformats.org/drawingml/2006/main">
-            <a:r>
-              <a:t/>
-            </a:r>
-          </a:p>
-          <a:p xmlns:a="http://schemas.openxmlformats.org/drawingml/2006/main">
-            <a:r>
-              <a:t>Evidence: README.md, monitor/pipeline.py, docs/integration-check.md in the project.</a:t>
             </a:r>
           </a:p>
         </p:txBody>
@@ -537,27 +525,13 @@
           <a:lstStyle xmlns:a="http://schemas.openxmlformats.org/drawingml/2006/main"/>
           <a:p xmlns:a="http://schemas.openxmlformats.org/drawingml/2006/main">
             <a:r>
-              <a:t>0:35–1:30</a:t>
-            </a:r>
-          </a:p>
+              <a:t>1:00-1:50</a:t>
+            </a:r>
+          </a:p>
+          <a:p xmlns:a="http://schemas.openxmlformats.org/drawingml/2006/main"/>
           <a:p xmlns:a="http://schemas.openxmlformats.org/drawingml/2006/main">
             <a:r>
-              <a:t/>
-            </a:r>
-          </a:p>
-          <a:p xmlns:a="http://schemas.openxmlformats.org/drawingml/2006/main">
-            <a:r>
-              <a:t>A refresh starts with NewsData.io and Data Centre Magazine. I save the metadata first, then use Newspaper4k to extract full text where possible. Similarity rules group related articles, and OpenRouter creates a description and labels each article for the feeds. One article can be relevant to both companies. SQLite stores the result, and the UI displays it after publication completes. The separation is straightforward: app.py handles presentation, pipeline.py coordinates the work, and the other modules own individual responsibilities. Normal page interactions only read saved results.</a:t>
-            </a:r>
-          </a:p>
-          <a:p xmlns:a="http://schemas.openxmlformats.org/drawingml/2006/main">
-            <a:r>
-              <a:t/>
-            </a:r>
-          </a:p>
-          <a:p xmlns:a="http://schemas.openxmlformats.org/drawingml/2006/main">
-            <a:r>
-              <a:t>Evidence: README.md, monitor/pipeline.py, docs/integration-check.md in the project.</a:t>
+              <a:t>A refresh runs four stages: discover, extract, group plus analyze, publish. The separation is straightforward: app.py handles presentation, pipeline.py coordinates the work, and the other modules own individual responsibilities. Normal page interactions only read saved results and never call the APIs.</a:t>
             </a:r>
           </a:p>
         </p:txBody>
@@ -588,7 +562,7 @@
 </file>
 
 <file path=ppt/notesSlides/notesSlide3.xml><?xml version="1.0" encoding="utf-8"?>
-<p:notes xmlns:p="http://schemas.openxmlformats.org/presentationml/2006/main">
+<p:notes xmlns:a="http://schemas.openxmlformats.org/drawingml/2006/main" xmlns:p="http://schemas.openxmlformats.org/presentationml/2006/main" xmlns:r="http://schemas.openxmlformats.org/officeDocument/2006/relationships">
   <p:cSld>
     <p:spTree>
       <p:nvGrpSpPr>
@@ -597,16 +571,21 @@
         <p:nvPr/>
       </p:nvGrpSpPr>
       <p:grpSpPr>
-        <a:xfrm xmlns:a="http://schemas.openxmlformats.org/drawingml/2006/main"/>
+        <a:xfrm>
+          <a:off x="0" y="0"/>
+          <a:ext cx="0" cy="0"/>
+          <a:chOff x="0" y="0"/>
+          <a:chExt cx="0" cy="0"/>
+        </a:xfrm>
       </p:grpSpPr>
       <p:sp>
         <p:nvSpPr>
           <p:cNvPr id="2" name="Slide Image Placeholder 1"/>
           <p:cNvSpPr>
-            <a:spLocks xmlns:a="http://schemas.openxmlformats.org/drawingml/2006/main" noGrp="1"/>
+            <a:spLocks noGrp="1"/>
           </p:cNvSpPr>
           <p:nvPr>
-            <p:ph type="sldImg" idx="0"/>
+            <p:ph type="sldImg" idx="2"/>
           </p:nvPr>
         </p:nvSpPr>
         <p:spPr/>
@@ -615,39 +594,25 @@
         <p:nvSpPr>
           <p:cNvPr id="3" name="Notes Placeholder 2"/>
           <p:cNvSpPr>
-            <a:spLocks xmlns:a="http://schemas.openxmlformats.org/drawingml/2006/main" noGrp="1"/>
+            <a:spLocks noGrp="1"/>
           </p:cNvSpPr>
           <p:nvPr>
-            <p:ph type="body" idx="1"/>
+            <p:ph type="body" idx="3" sz="quarter"/>
           </p:nvPr>
         </p:nvSpPr>
         <p:spPr/>
         <p:txBody>
-          <a:bodyPr xmlns:a="http://schemas.openxmlformats.org/drawingml/2006/main"/>
-          <a:lstStyle xmlns:a="http://schemas.openxmlformats.org/drawingml/2006/main"/>
-          <a:p xmlns:a="http://schemas.openxmlformats.org/drawingml/2006/main">
-            <a:r>
-              <a:t>1:30–2:25</a:t>
-            </a:r>
-          </a:p>
-          <a:p xmlns:a="http://schemas.openxmlformats.org/drawingml/2006/main">
-            <a:r>
-              <a:t/>
-            </a:r>
-          </a:p>
-          <a:p xmlns:a="http://schemas.openxmlformats.org/drawingml/2006/main">
-            <a:r>
-              <a:t>I chose Streamlit because this task needs a working dashboard and one deployment. SQLite gives us persistence without running another service. The trade-off is that this design assumes one app process. YAML keeps settings simple, although a settings screen would be easier for nontechnical users. TF-IDF grouping is cheap and understandable, but it can miss paraphrases or confuse similar events. I ask the LLM for the summary and relevance together, and reuse successful results when the inputs match. Pydantic validates the response structure and article IDs. It cannot prove that the summary is factually correct.</a:t>
-            </a:r>
-          </a:p>
-          <a:p xmlns:a="http://schemas.openxmlformats.org/drawingml/2006/main">
-            <a:r>
-              <a:t/>
-            </a:r>
-          </a:p>
-          <a:p xmlns:a="http://schemas.openxmlformats.org/drawingml/2006/main">
-            <a:r>
-              <a:t>Evidence: README.md, monitor/pipeline.py, docs/integration-check.md in the project.</a:t>
+          <a:bodyPr/>
+          <a:lstStyle/>
+          <a:p>
+            <a:r>
+              <a:t>0:30-1:00</a:t>
+            </a:r>
+          </a:p>
+          <a:p/>
+          <a:p>
+            <a:r>
+              <a:t>This is the full implementation path: discovery from NewsData.io and Data Centre Magazine, full-text extraction, persistence, grouping, LLM analysis, and dashboard publication. The industry feed reuses the same saved articles and analysis flow, with no separate pipeline.</a:t>
             </a:r>
           </a:p>
         </p:txBody>
@@ -656,23 +621,18 @@
         <p:nvSpPr>
           <p:cNvPr id="4" name="Slide Number Placeholder 3"/>
           <p:cNvSpPr>
-            <a:spLocks xmlns:a="http://schemas.openxmlformats.org/drawingml/2006/main" noGrp="1"/>
+            <a:spLocks noGrp="1"/>
           </p:cNvSpPr>
           <p:nvPr>
-            <p:ph type="sldNum" idx="5"/>
+            <p:ph type="sldNum" idx="5" sz="quarter"/>
           </p:nvPr>
         </p:nvSpPr>
         <p:spPr/>
-        <p:txBody>
-          <a:bodyPr xmlns:a="http://schemas.openxmlformats.org/drawingml/2006/main"/>
-          <a:lstStyle xmlns:a="http://schemas.openxmlformats.org/drawingml/2006/main"/>
-          <a:p xmlns:a="http://schemas.openxmlformats.org/drawingml/2006/main"/>
-        </p:txBody>
       </p:sp>
     </p:spTree>
   </p:cSld>
   <p:clrMapOvr>
-    <a:masterClrMapping xmlns:a="http://schemas.openxmlformats.org/drawingml/2006/main"/>
+    <a:masterClrMapping/>
   </p:clrMapOvr>
 </p:notes>
 </file>
@@ -717,27 +677,13 @@
           <a:lstStyle xmlns:a="http://schemas.openxmlformats.org/drawingml/2006/main"/>
           <a:p xmlns:a="http://schemas.openxmlformats.org/drawingml/2006/main">
             <a:r>
-              <a:t>2:25–3:25</a:t>
-            </a:r>
-          </a:p>
+              <a:t>2:40-3:30</a:t>
+            </a:r>
+          </a:p>
+          <a:p xmlns:a="http://schemas.openxmlformats.org/drawingml/2006/main"/>
           <a:p xmlns:a="http://schemas.openxmlformats.org/drawingml/2006/main">
             <a:r>
-              <a:t/>
-            </a:r>
-          </a:p>
-          <a:p xmlns:a="http://schemas.openxmlformats.org/drawingml/2006/main">
-            <a:r>
-              <a:t>I handled failures as part of the normal flow. If a publisher blocks extraction, I keep the snippet and label the limitation. If one source fails, the other can still contribute. If both fail, the previous published results remain available. Missing keys, invalid model output, or the request budget trigger a headline and keyword fallback. A shared lock prevents overlapping refreshes in one process, while normal reruns do not call APIs. Unknown dates stay unknown. Changing the tracked companies hides old classifications until a new refresh. Grouping and source timestamps still have quality limits, which I would measure with a labeled sample.</a:t>
-            </a:r>
-          </a:p>
-          <a:p xmlns:a="http://schemas.openxmlformats.org/drawingml/2006/main">
-            <a:r>
-              <a:t/>
-            </a:r>
-          </a:p>
-          <a:p xmlns:a="http://schemas.openxmlformats.org/drawingml/2006/main">
-            <a:r>
-              <a:t>Evidence: README.md, monitor/pipeline.py, docs/integration-check.md in the project.</a:t>
+              <a:t>I handled failures as part of the normal flow. Blocked extraction keeps the snippet with a visible label. One failed source still leaves the other. Total failure keeps the previous snapshot visible. A missing key, invalid output, or exhausted budget falls back to a headline and keyword match, trying a second model first when configured. A process-wide lock stops overlapping refreshes, and unknown dates stay unknown.</a:t>
             </a:r>
           </a:p>
         </p:txBody>
@@ -807,27 +753,13 @@
           <a:lstStyle xmlns:a="http://schemas.openxmlformats.org/drawingml/2006/main"/>
           <a:p xmlns:a="http://schemas.openxmlformats.org/drawingml/2006/main">
             <a:r>
-              <a:t>3:25–4:05</a:t>
-            </a:r>
-          </a:p>
+              <a:t>3:30-4:10</a:t>
+            </a:r>
+          </a:p>
+          <a:p xmlns:a="http://schemas.openxmlformats.org/drawingml/2006/main"/>
           <a:p xmlns:a="http://schemas.openxmlformats.org/drawingml/2006/main">
             <a:r>
-              <a:t/>
-            </a:r>
-          </a:p>
-          <a:p xmlns:a="http://schemas.openxmlformats.org/drawingml/2006/main">
-            <a:r>
-              <a:t>The automated suite has 133 passing tests, locally and inside the Linux container. It covers data preservation, malformed responses, grouping examples, UI reruns, and concurrent refreshes. I also tested real sources and OpenRouter. Docker runs as a non-root user and stores SQLite in a named volume. A health check confirms that Streamlit is serving, while a real refresh checks the integrations. For the demo, I keep a completed refresh saved so provider latency does not interrupt the walkthrough. These checks demonstrate behavior. They are not a benchmark of summary or grouping accuracy.</a:t>
-            </a:r>
-          </a:p>
-          <a:p xmlns:a="http://schemas.openxmlformats.org/drawingml/2006/main">
-            <a:r>
-              <a:t/>
-            </a:r>
-          </a:p>
-          <a:p xmlns:a="http://schemas.openxmlformats.org/drawingml/2006/main">
-            <a:r>
-              <a:t>Evidence: README.md, monitor/pipeline.py, docs/integration-check.md in the project.</a:t>
+              <a:t>145 tests pass locally and inside the Linux container, covering persistence, malformed responses, grouping, two-model fallback, UI reruns, and concurrent refreshes. Live checks cover both sources and OpenRouter, Docker runs non-root with a named volume that survived recreation. These checks demonstrate behavior, not summary accuracy.</a:t>
             </a:r>
           </a:p>
         </p:txBody>
@@ -897,27 +829,13 @@
           <a:lstStyle xmlns:a="http://schemas.openxmlformats.org/drawingml/2006/main"/>
           <a:p xmlns:a="http://schemas.openxmlformats.org/drawingml/2006/main">
             <a:r>
-              <a:t>4:05–5:00</a:t>
-            </a:r>
-          </a:p>
+              <a:t>4:10-5:00</a:t>
+            </a:r>
+          </a:p>
+          <a:p xmlns:a="http://schemas.openxmlformats.org/drawingml/2006/main"/>
           <a:p xmlns:a="http://schemas.openxmlformats.org/drawingml/2006/main">
             <a:r>
-              <a:t/>
-            </a:r>
-          </a:p>
-          <a:p xmlns:a="http://schemas.openxmlformats.org/drawingml/2006/main">
-            <a:r>
-              <a:t>First, I would build a labeled news sample and measure grouping, relevance, and summary quality. That tells me whether better thresholds, embeddings, or a different model actually help. For production, I would add authentication, managed secrets, API usage controls, and tested backups. Scheduled monitoring needs background jobs, durable retries, and metrics for failures and cost. Multiple workers would justify PostgreSQL and shared job coordination. On the UI, I would prioritize easier settings and clearer freshness before adding more features. I would introduce FastAPI or a separate frontend when other clients or richer interactions justify those extra boundaries.</a:t>
-            </a:r>
-          </a:p>
-          <a:p xmlns:a="http://schemas.openxmlformats.org/drawingml/2006/main">
-            <a:r>
-              <a:t/>
-            </a:r>
-          </a:p>
-          <a:p xmlns:a="http://schemas.openxmlformats.org/drawingml/2006/main">
-            <a:r>
-              <a:t>Evidence: README.md, monitor/pipeline.py, docs/integration-check.md in the project.</a:t>
+              <a:t>First, build a labeled news sample and measure grouping, relevance, and summary quality before changing models. For production: authentication, managed secrets, API limits, tested backups, scheduled jobs with retries, and metrics for failures and cost. Multiple workers justify PostgreSQL and shared coordination.</a:t>
             </a:r>
           </a:p>
         </p:txBody>
@@ -943,6 +861,158 @@
   </p:cSld>
   <p:clrMapOvr>
     <a:masterClrMapping xmlns:a="http://schemas.openxmlformats.org/drawingml/2006/main"/>
+  </p:clrMapOvr>
+</p:notes>
+</file>
+
+<file path=ppt/notesSlides/notesSlide7.xml><?xml version="1.0" encoding="utf-8"?>
+<p:notes xmlns:a="http://schemas.openxmlformats.org/drawingml/2006/main" xmlns:p="http://schemas.openxmlformats.org/presentationml/2006/main" xmlns:r="http://schemas.openxmlformats.org/officeDocument/2006/relationships">
+  <p:cSld>
+    <p:spTree>
+      <p:nvGrpSpPr>
+        <p:cNvPr id="1" name=""/>
+        <p:cNvGrpSpPr/>
+        <p:nvPr/>
+      </p:nvGrpSpPr>
+      <p:grpSpPr>
+        <a:xfrm>
+          <a:off x="0" y="0"/>
+          <a:ext cx="0" cy="0"/>
+          <a:chOff x="0" y="0"/>
+          <a:chExt cx="0" cy="0"/>
+        </a:xfrm>
+      </p:grpSpPr>
+      <p:sp>
+        <p:nvSpPr>
+          <p:cNvPr id="2" name="Slide Image Placeholder 1"/>
+          <p:cNvSpPr>
+            <a:spLocks noGrp="1"/>
+          </p:cNvSpPr>
+          <p:nvPr>
+            <p:ph type="sldImg" idx="2"/>
+          </p:nvPr>
+        </p:nvSpPr>
+        <p:spPr/>
+      </p:sp>
+      <p:sp>
+        <p:nvSpPr>
+          <p:cNvPr id="3" name="Notes Placeholder 2"/>
+          <p:cNvSpPr>
+            <a:spLocks noGrp="1"/>
+          </p:cNvSpPr>
+          <p:nvPr>
+            <p:ph type="body" idx="3" sz="quarter"/>
+          </p:nvPr>
+        </p:nvSpPr>
+        <p:spPr/>
+        <p:txBody>
+          <a:bodyPr/>
+          <a:lstStyle/>
+          <a:p>
+            <a:r>
+              <a:t>1:50-2:40</a:t>
+            </a:r>
+          </a:p>
+          <a:p/>
+          <a:p>
+            <a:r>
+              <a:t>Each choice was cheap on purpose and has a defined prod exit. Streamlit becomes FastAPI plus a frontend when other clients need it. SQLite plus a process lock becomes PostgreSQL with queued jobs and shared coordination. TF-IDF gets an embeddings verifier only if a labeled sample proves misses. The mini model plus fallback gets re-picked from measured quality and cost. YAML becomes a settings UI for non-technical editors. One container gains auth, secrets, backups, and alerts before public use.</a:t>
+            </a:r>
+          </a:p>
+        </p:txBody>
+      </p:sp>
+      <p:sp>
+        <p:nvSpPr>
+          <p:cNvPr id="4" name="Slide Number Placeholder 3"/>
+          <p:cNvSpPr>
+            <a:spLocks noGrp="1"/>
+          </p:cNvSpPr>
+          <p:nvPr>
+            <p:ph type="sldNum" idx="5" sz="quarter"/>
+          </p:nvPr>
+        </p:nvSpPr>
+        <p:spPr/>
+      </p:sp>
+    </p:spTree>
+  </p:cSld>
+  <p:clrMapOvr>
+    <a:masterClrMapping/>
+  </p:clrMapOvr>
+</p:notes>
+</file>
+
+<file path=ppt/notesSlides/notesSlide8.xml><?xml version="1.0" encoding="utf-8"?>
+<p:notes xmlns:a="http://schemas.openxmlformats.org/drawingml/2006/main" xmlns:p="http://schemas.openxmlformats.org/presentationml/2006/main" xmlns:r="http://schemas.openxmlformats.org/officeDocument/2006/relationships">
+  <p:cSld>
+    <p:spTree>
+      <p:nvGrpSpPr>
+        <p:cNvPr id="1" name=""/>
+        <p:cNvGrpSpPr/>
+        <p:nvPr/>
+      </p:nvGrpSpPr>
+      <p:grpSpPr>
+        <a:xfrm>
+          <a:off x="0" y="0"/>
+          <a:ext cx="0" cy="0"/>
+          <a:chOff x="0" y="0"/>
+          <a:chExt cx="0" cy="0"/>
+        </a:xfrm>
+      </p:grpSpPr>
+      <p:sp>
+        <p:nvSpPr>
+          <p:cNvPr id="2" name="Slide Image Placeholder 1"/>
+          <p:cNvSpPr>
+            <a:spLocks noGrp="1"/>
+          </p:cNvSpPr>
+          <p:nvPr>
+            <p:ph type="sldImg" idx="2"/>
+          </p:nvPr>
+        </p:nvSpPr>
+        <p:spPr/>
+      </p:sp>
+      <p:sp>
+        <p:nvSpPr>
+          <p:cNvPr id="3" name="Notes Placeholder 2"/>
+          <p:cNvSpPr>
+            <a:spLocks noGrp="1"/>
+          </p:cNvSpPr>
+          <p:nvPr>
+            <p:ph type="body" idx="3" sz="quarter"/>
+          </p:nvPr>
+        </p:nvSpPr>
+        <p:spPr/>
+        <p:txBody>
+          <a:bodyPr/>
+          <a:lstStyle/>
+          <a:p>
+            <a:r>
+              <a:t>Backup, only if asked</a:t>
+            </a:r>
+          </a:p>
+          <a:p/>
+          <a:p>
+            <a:r>
+              <a:t>Every number is a budget: 25 articles per source, 7-day window, 60-second source budgets. 2MB pages, 15 seconds per article, 50-word minimum. 200 articles grouped, 8 per story, 0.42 similarity. 4k characters per article, 20 calls in 90 seconds, 2 models, 80-word summaries.</a:t>
+            </a:r>
+          </a:p>
+        </p:txBody>
+      </p:sp>
+      <p:sp>
+        <p:nvSpPr>
+          <p:cNvPr id="4" name="Slide Number Placeholder 3"/>
+          <p:cNvSpPr>
+            <a:spLocks noGrp="1"/>
+          </p:cNvSpPr>
+          <p:nvPr>
+            <p:ph type="sldNum" idx="5" sz="quarter"/>
+          </p:nvPr>
+        </p:nvSpPr>
+        <p:spPr/>
+      </p:sp>
+    </p:spTree>
+  </p:cSld>
+  <p:clrMapOvr>
+    <a:masterClrMapping/>
   </p:clrMapOvr>
 </p:notes>
 </file>
@@ -1920,7 +1990,7 @@
                 <a:ea typeface="Helvetica Neue"/>
                 <a:cs typeface="Helvetica Neue"/>
               </a:rPr>
-              <a:t>02</a:t>
+              <a:t>03</a:t>
             </a:r>
           </a:p>
         </p:txBody>
@@ -2613,542 +2683,6 @@
     <p:extLst>
       <p:ext uri="{BB962C8B-B14F-4D97-AF65-F5344CB8AC3E}">
         <p14:creationId xmlns:p14="http://schemas.microsoft.com/office/powerpoint/2010/main" val="1925972886"/>
-      </p:ext>
-    </p:extLst>
-  </p:cSld>
-</p:sld>
-</file>
-
-<file path=ppt/slides/slide3.xml><?xml version="1.0" encoding="utf-8"?>
-<p:sld xmlns:p="http://schemas.openxmlformats.org/presentationml/2006/main">
-  <p:cSld>
-    <p:bg>
-      <p:bgPr>
-        <a:solidFill xmlns:a="http://schemas.openxmlformats.org/drawingml/2006/main">
-          <a:srgbClr val="FFFFFF"/>
-        </a:solidFill>
-      </p:bgPr>
-    </p:bg>
-    <p:spTree>
-      <p:nvGrpSpPr>
-        <p:cNvPr id="1" name=""/>
-        <p:cNvGrpSpPr/>
-        <p:nvPr/>
-      </p:nvGrpSpPr>
-      <p:grpSpPr>
-        <a:xfrm xmlns:a="http://schemas.openxmlformats.org/drawingml/2006/main"/>
-      </p:grpSpPr>
-      <p:sp>
-        <p:nvSpPr>
-          <p:cNvPr id="4" name="">
-            <a:extLst xmlns:a="http://schemas.openxmlformats.org/drawingml/2006/main">
-              <a:ext uri="{FF2B5EF4-FFF2-40B4-BE49-F238E27FC236}">
-                <a16:creationId xmlns:a16="http://schemas.microsoft.com/office/drawing/2014/main" id="{EE5CAD81-EF00-438B-AE28-8506CF02FD1F}"/>
-              </a:ext>
-            </a:extLst>
-          </p:cNvPr>
-          <p:cNvSpPr>
-            <a:spLocks xmlns:a="http://schemas.openxmlformats.org/drawingml/2006/main" noGrp="1"/>
-          </p:cNvSpPr>
-          <p:nvPr/>
-        </p:nvSpPr>
-        <p:spPr>
-          <a:xfrm xmlns:a="http://schemas.openxmlformats.org/drawingml/2006/main">
-            <a:off x="723900" y="590550"/>
-            <a:ext cx="10744200" cy="819150"/>
-          </a:xfrm>
-          <a:prstGeom xmlns:a="http://schemas.openxmlformats.org/drawingml/2006/main" prst="rect">
-            <a:avLst/>
-          </a:prstGeom>
-          <a:noFill xmlns:a="http://schemas.openxmlformats.org/drawingml/2006/main"/>
-          <a:ln xmlns:a="http://schemas.openxmlformats.org/drawingml/2006/main" w="0">
-            <a:noFill/>
-          </a:ln>
-        </p:spPr>
-        <p:txBody>
-          <a:bodyPr xmlns:a="http://schemas.openxmlformats.org/drawingml/2006/main">
-            <a:noAutofit/>
-          </a:bodyPr>
-          <a:lstStyle xmlns:a="http://schemas.openxmlformats.org/drawingml/2006/main"/>
-          <a:p xmlns:a="http://schemas.openxmlformats.org/drawingml/2006/main">
-            <a:pPr>
-              <a:defRPr sz="3450" b="1">
-                <a:solidFill>
-                  <a:srgbClr val="172B4D"/>
-                </a:solidFill>
-                <a:latin typeface="Helvetica Neue"/>
-                <a:ea typeface="Helvetica Neue"/>
-                <a:cs typeface="Helvetica Neue"/>
-              </a:defRPr>
-            </a:pPr>
-            <a:r>
-              <a:rPr sz="3450" b="1">
-                <a:solidFill>
-                  <a:srgbClr val="172B4D"/>
-                </a:solidFill>
-                <a:latin typeface="Helvetica Neue"/>
-                <a:ea typeface="Helvetica Neue"/>
-                <a:cs typeface="Helvetica Neue"/>
-              </a:rPr>
-              <a:t>Key choices and trade-offs</a:t>
-            </a:r>
-          </a:p>
-        </p:txBody>
-      </p:sp>
-      <p:sp>
-        <p:nvSpPr>
-          <p:cNvPr id="2" name="">
-            <a:extLst xmlns:a="http://schemas.openxmlformats.org/drawingml/2006/main">
-              <a:ext uri="{FF2B5EF4-FFF2-40B4-BE49-F238E27FC236}">
-                <a16:creationId xmlns:a16="http://schemas.microsoft.com/office/drawing/2014/main" id="{3BDDF276-1FBA-45A4-9ADA-7D77B1DFA4B2}"/>
-              </a:ext>
-            </a:extLst>
-          </p:cNvPr>
-          <p:cNvSpPr>
-            <a:spLocks xmlns:a="http://schemas.openxmlformats.org/drawingml/2006/main" noGrp="1"/>
-          </p:cNvSpPr>
-          <p:nvPr/>
-        </p:nvSpPr>
-        <p:spPr>
-          <a:xfrm xmlns:a="http://schemas.openxmlformats.org/drawingml/2006/main">
-            <a:off x="10953750" y="6238875"/>
-            <a:ext cx="571500" cy="285750"/>
-          </a:xfrm>
-          <a:prstGeom xmlns:a="http://schemas.openxmlformats.org/drawingml/2006/main" prst="rect">
-            <a:avLst/>
-          </a:prstGeom>
-          <a:noFill xmlns:a="http://schemas.openxmlformats.org/drawingml/2006/main"/>
-          <a:ln xmlns:a="http://schemas.openxmlformats.org/drawingml/2006/main" w="0">
-            <a:noFill/>
-          </a:ln>
-        </p:spPr>
-        <p:txBody>
-          <a:bodyPr xmlns:a="http://schemas.openxmlformats.org/drawingml/2006/main">
-            <a:noAutofit/>
-          </a:bodyPr>
-          <a:lstStyle xmlns:a="http://schemas.openxmlformats.org/drawingml/2006/main"/>
-          <a:p xmlns:a="http://schemas.openxmlformats.org/drawingml/2006/main">
-            <a:pPr>
-              <a:defRPr sz="1500" b="0">
-                <a:solidFill>
-                  <a:srgbClr val="526176"/>
-                </a:solidFill>
-                <a:latin typeface="Helvetica Neue"/>
-                <a:ea typeface="Helvetica Neue"/>
-                <a:cs typeface="Helvetica Neue"/>
-              </a:defRPr>
-            </a:pPr>
-            <a:r>
-              <a:rPr sz="1500" b="0">
-                <a:solidFill>
-                  <a:srgbClr val="526176"/>
-                </a:solidFill>
-                <a:latin typeface="Helvetica Neue"/>
-                <a:ea typeface="Helvetica Neue"/>
-                <a:cs typeface="Helvetica Neue"/>
-              </a:rPr>
-              <a:t>03</a:t>
-            </a:r>
-          </a:p>
-        </p:txBody>
-      </p:sp>
-      <p:graphicFrame>
-        <p:nvGraphicFramePr>
-          <p:cNvPr id="6" name=""/>
-          <p:cNvGraphicFramePr/>
-          <p:nvPr/>
-        </p:nvGraphicFramePr>
-        <p:xfrm>
-          <a:off xmlns:a="http://schemas.openxmlformats.org/drawingml/2006/main" x="723900" y="1809750"/>
-          <a:ext xmlns:a="http://schemas.openxmlformats.org/drawingml/2006/main" cx="10744200" cy="3905250"/>
-        </p:xfrm>
-        <a:graphic xmlns:a="http://schemas.openxmlformats.org/drawingml/2006/main">
-          <a:graphicData uri="http://schemas.openxmlformats.org/drawingml/2006/table">
-            <a:tbl>
-              <a:tblPr/>
-              <a:tblGrid>
-                <a:gridCol w="2952750"/>
-                <a:gridCol w="3762375"/>
-                <a:gridCol w="4029075"/>
-              </a:tblGrid>
-              <a:tr h="571500">
-                <a:tc>
-                  <a:txBody>
-                    <a:bodyPr/>
-                    <a:lstStyle/>
-                    <a:p>
-                      <a:r>
-                        <a:rPr sz="1875" b="1">
-                          <a:solidFill>
-                            <a:srgbClr val="172B4D"/>
-                          </a:solidFill>
-                          <a:latin typeface="Helvetica Neue"/>
-                          <a:ea typeface="Helvetica Neue"/>
-                          <a:cs typeface="Helvetica Neue"/>
-                        </a:rPr>
-                        <a:t>Choice</a:t>
-                      </a:r>
-                    </a:p>
-                  </a:txBody>
-                  <a:tcPr marL="91440" marR="91440" marT="45720" marB="45720">
-                    <a:solidFill>
-                      <a:srgbClr val="EAF0F8"/>
-                    </a:solidFill>
-                  </a:tcPr>
-                </a:tc>
-                <a:tc>
-                  <a:txBody>
-                    <a:bodyPr/>
-                    <a:lstStyle/>
-                    <a:p>
-                      <a:r>
-                        <a:rPr sz="1875" b="1">
-                          <a:solidFill>
-                            <a:srgbClr val="526176"/>
-                          </a:solidFill>
-                          <a:latin typeface="Helvetica Neue"/>
-                          <a:ea typeface="Helvetica Neue"/>
-                          <a:cs typeface="Helvetica Neue"/>
-                        </a:rPr>
-                        <a:t>Why it fits</a:t>
-                      </a:r>
-                    </a:p>
-                  </a:txBody>
-                  <a:tcPr marL="91440" marR="91440" marT="45720" marB="45720">
-                    <a:solidFill>
-                      <a:srgbClr val="EAF0F8"/>
-                    </a:solidFill>
-                  </a:tcPr>
-                </a:tc>
-                <a:tc>
-                  <a:txBody>
-                    <a:bodyPr/>
-                    <a:lstStyle/>
-                    <a:p>
-                      <a:r>
-                        <a:rPr sz="1875" b="1">
-                          <a:solidFill>
-                            <a:srgbClr val="526176"/>
-                          </a:solidFill>
-                          <a:latin typeface="Helvetica Neue"/>
-                          <a:ea typeface="Helvetica Neue"/>
-                          <a:cs typeface="Helvetica Neue"/>
-                        </a:rPr>
-                        <a:t>Trade-off</a:t>
-                      </a:r>
-                    </a:p>
-                  </a:txBody>
-                  <a:tcPr marL="91440" marR="91440" marT="45720" marB="45720">
-                    <a:solidFill>
-                      <a:srgbClr val="EAF0F8"/>
-                    </a:solidFill>
-                  </a:tcPr>
-                </a:tc>
-              </a:tr>
-              <a:tr h="833438">
-                <a:tc>
-                  <a:txBody>
-                    <a:bodyPr/>
-                    <a:lstStyle/>
-                    <a:p>
-                      <a:r>
-                        <a:rPr sz="1950" b="1">
-                          <a:solidFill>
-                            <a:srgbClr val="172B4D"/>
-                          </a:solidFill>
-                          <a:latin typeface="Helvetica Neue"/>
-                          <a:ea typeface="Helvetica Neue"/>
-                          <a:cs typeface="Helvetica Neue"/>
-                        </a:rPr>
-                        <a:t>Streamlit + SQLite</a:t>
-                      </a:r>
-                    </a:p>
-                  </a:txBody>
-                  <a:tcPr marL="91440" marR="91440" marT="45720" marB="45720">
-                    <a:solidFill>
-                      <a:srgbClr val="FFFFFF"/>
-                    </a:solidFill>
-                  </a:tcPr>
-                </a:tc>
-                <a:tc>
-                  <a:txBody>
-                    <a:bodyPr/>
-                    <a:lstStyle/>
-                    <a:p>
-                      <a:r>
-                        <a:rPr sz="1950" b="0">
-                          <a:solidFill>
-                            <a:srgbClr val="526176"/>
-                          </a:solidFill>
-                          <a:latin typeface="Helvetica Neue"/>
-                          <a:ea typeface="Helvetica Neue"/>
-                          <a:cs typeface="Helvetica Neue"/>
-                        </a:rPr>
-                        <a:t>One app to run</a:t>
-                      </a:r>
-                    </a:p>
-                  </a:txBody>
-                  <a:tcPr marL="91440" marR="91440" marT="45720" marB="45720">
-                    <a:solidFill>
-                      <a:srgbClr val="FFFFFF"/>
-                    </a:solidFill>
-                  </a:tcPr>
-                </a:tc>
-                <a:tc>
-                  <a:txBody>
-                    <a:bodyPr/>
-                    <a:lstStyle/>
-                    <a:p>
-                      <a:r>
-                        <a:rPr sz="1950" b="0">
-                          <a:solidFill>
-                            <a:srgbClr val="526176"/>
-                          </a:solidFill>
-                          <a:latin typeface="Helvetica Neue"/>
-                          <a:ea typeface="Helvetica Neue"/>
-                          <a:cs typeface="Helvetica Neue"/>
-                        </a:rPr>
-                        <a:t>One process assumption</a:t>
-                      </a:r>
-                    </a:p>
-                  </a:txBody>
-                  <a:tcPr marL="91440" marR="91440" marT="45720" marB="45720">
-                    <a:solidFill>
-                      <a:srgbClr val="FFFFFF"/>
-                    </a:solidFill>
-                  </a:tcPr>
-                </a:tc>
-              </a:tr>
-              <a:tr h="833438">
-                <a:tc>
-                  <a:txBody>
-                    <a:bodyPr/>
-                    <a:lstStyle/>
-                    <a:p>
-                      <a:r>
-                        <a:rPr sz="1950" b="1">
-                          <a:solidFill>
-                            <a:srgbClr val="172B4D"/>
-                          </a:solidFill>
-                          <a:latin typeface="Helvetica Neue"/>
-                          <a:ea typeface="Helvetica Neue"/>
-                          <a:cs typeface="Helvetica Neue"/>
-                        </a:rPr>
-                        <a:t>YAML settings</a:t>
-                      </a:r>
-                    </a:p>
-                  </a:txBody>
-                  <a:tcPr marL="91440" marR="91440" marT="45720" marB="45720">
-                    <a:solidFill>
-                      <a:srgbClr val="FFFFFF"/>
-                    </a:solidFill>
-                  </a:tcPr>
-                </a:tc>
-                <a:tc>
-                  <a:txBody>
-                    <a:bodyPr/>
-                    <a:lstStyle/>
-                    <a:p>
-                      <a:r>
-                        <a:rPr sz="1950" b="0">
-                          <a:solidFill>
-                            <a:srgbClr val="526176"/>
-                          </a:solidFill>
-                          <a:latin typeface="Helvetica Neue"/>
-                          <a:ea typeface="Helvetica Neue"/>
-                          <a:cs typeface="Helvetica Neue"/>
-                        </a:rPr>
-                        <a:t>Easy to review and edit</a:t>
-                      </a:r>
-                    </a:p>
-                  </a:txBody>
-                  <a:tcPr marL="91440" marR="91440" marT="45720" marB="45720">
-                    <a:solidFill>
-                      <a:srgbClr val="FFFFFF"/>
-                    </a:solidFill>
-                  </a:tcPr>
-                </a:tc>
-                <a:tc>
-                  <a:txBody>
-                    <a:bodyPr/>
-                    <a:lstStyle/>
-                    <a:p>
-                      <a:r>
-                        <a:rPr sz="1950" b="0">
-                          <a:solidFill>
-                            <a:srgbClr val="526176"/>
-                          </a:solidFill>
-                          <a:latin typeface="Helvetica Neue"/>
-                          <a:ea typeface="Helvetica Neue"/>
-                          <a:cs typeface="Helvetica Neue"/>
-                        </a:rPr>
-                        <a:t>Restart after changes</a:t>
-                      </a:r>
-                    </a:p>
-                  </a:txBody>
-                  <a:tcPr marL="91440" marR="91440" marT="45720" marB="45720">
-                    <a:solidFill>
-                      <a:srgbClr val="FFFFFF"/>
-                    </a:solidFill>
-                  </a:tcPr>
-                </a:tc>
-              </a:tr>
-              <a:tr h="833438">
-                <a:tc>
-                  <a:txBody>
-                    <a:bodyPr/>
-                    <a:lstStyle/>
-                    <a:p>
-                      <a:r>
-                        <a:rPr sz="1950" b="1">
-                          <a:solidFill>
-                            <a:srgbClr val="172B4D"/>
-                          </a:solidFill>
-                          <a:latin typeface="Helvetica Neue"/>
-                          <a:ea typeface="Helvetica Neue"/>
-                          <a:cs typeface="Helvetica Neue"/>
-                        </a:rPr>
-                        <a:t>TF-IDF grouping</a:t>
-                      </a:r>
-                    </a:p>
-                  </a:txBody>
-                  <a:tcPr marL="91440" marR="91440" marT="45720" marB="45720">
-                    <a:solidFill>
-                      <a:srgbClr val="FFFFFF"/>
-                    </a:solidFill>
-                  </a:tcPr>
-                </a:tc>
-                <a:tc>
-                  <a:txBody>
-                    <a:bodyPr/>
-                    <a:lstStyle/>
-                    <a:p>
-                      <a:r>
-                        <a:rPr sz="1950" b="0">
-                          <a:solidFill>
-                            <a:srgbClr val="526176"/>
-                          </a:solidFill>
-                          <a:latin typeface="Helvetica Neue"/>
-                          <a:ea typeface="Helvetica Neue"/>
-                          <a:cs typeface="Helvetica Neue"/>
-                        </a:rPr>
-                        <a:t>Cheap and explainable</a:t>
-                      </a:r>
-                    </a:p>
-                  </a:txBody>
-                  <a:tcPr marL="91440" marR="91440" marT="45720" marB="45720">
-                    <a:solidFill>
-                      <a:srgbClr val="FFFFFF"/>
-                    </a:solidFill>
-                  </a:tcPr>
-                </a:tc>
-                <a:tc>
-                  <a:txBody>
-                    <a:bodyPr/>
-                    <a:lstStyle/>
-                    <a:p>
-                      <a:r>
-                        <a:rPr sz="1950" b="0">
-                          <a:solidFill>
-                            <a:srgbClr val="526176"/>
-                          </a:solidFill>
-                          <a:latin typeface="Helvetica Neue"/>
-                          <a:ea typeface="Helvetica Neue"/>
-                          <a:cs typeface="Helvetica Neue"/>
-                        </a:rPr>
-                        <a:t>Can miss paraphrases</a:t>
-                      </a:r>
-                    </a:p>
-                  </a:txBody>
-                  <a:tcPr marL="91440" marR="91440" marT="45720" marB="45720">
-                    <a:solidFill>
-                      <a:srgbClr val="FFFFFF"/>
-                    </a:solidFill>
-                  </a:tcPr>
-                </a:tc>
-              </a:tr>
-              <a:tr h="833438">
-                <a:tc>
-                  <a:txBody>
-                    <a:bodyPr/>
-                    <a:lstStyle/>
-                    <a:p>
-                      <a:r>
-                        <a:rPr sz="1950" b="1">
-                          <a:solidFill>
-                            <a:srgbClr val="172B4D"/>
-                          </a:solidFill>
-                          <a:latin typeface="Helvetica Neue"/>
-                          <a:ea typeface="Helvetica Neue"/>
-                          <a:cs typeface="Helvetica Neue"/>
-                        </a:rPr>
-                        <a:t>LLM + validation</a:t>
-                      </a:r>
-                    </a:p>
-                  </a:txBody>
-                  <a:tcPr marL="91440" marR="91440" marT="45720" marB="45720">
-                    <a:solidFill>
-                      <a:srgbClr val="FFFFFF"/>
-                    </a:solidFill>
-                  </a:tcPr>
-                </a:tc>
-                <a:tc>
-                  <a:txBody>
-                    <a:bodyPr/>
-                    <a:lstStyle/>
-                    <a:p>
-                      <a:r>
-                        <a:rPr sz="1950" b="0">
-                          <a:solidFill>
-                            <a:srgbClr val="526176"/>
-                          </a:solidFill>
-                          <a:latin typeface="Helvetica Neue"/>
-                          <a:ea typeface="Helvetica Neue"/>
-                          <a:cs typeface="Helvetica Neue"/>
-                        </a:rPr>
-                        <a:t>Summary and relevance together</a:t>
-                      </a:r>
-                    </a:p>
-                  </a:txBody>
-                  <a:tcPr marL="91440" marR="91440" marT="45720" marB="45720">
-                    <a:solidFill>
-                      <a:srgbClr val="FFFFFF"/>
-                    </a:solidFill>
-                  </a:tcPr>
-                </a:tc>
-                <a:tc>
-                  <a:txBody>
-                    <a:bodyPr/>
-                    <a:lstStyle/>
-                    <a:p>
-                      <a:r>
-                        <a:rPr sz="1950" b="0">
-                          <a:solidFill>
-                            <a:srgbClr val="526176"/>
-                          </a:solidFill>
-                          <a:latin typeface="Helvetica Neue"/>
-                          <a:ea typeface="Helvetica Neue"/>
-                          <a:cs typeface="Helvetica Neue"/>
-                        </a:rPr>
-                        <a:t>Quality needs evaluation</a:t>
-                      </a:r>
-                    </a:p>
-                  </a:txBody>
-                  <a:tcPr marL="91440" marR="91440" marT="45720" marB="45720">
-                    <a:solidFill>
-                      <a:srgbClr val="FFFFFF"/>
-                    </a:solidFill>
-                  </a:tcPr>
-                </a:tc>
-              </a:tr>
-            </a:tbl>
-          </a:graphicData>
-        </a:graphic>
-      </p:graphicFrame>
-    </p:spTree>
-    <p:extLst>
-      <p:ext uri="{BB962C8B-B14F-4D97-AF65-F5344CB8AC3E}">
-        <p14:creationId xmlns:p14="http://schemas.microsoft.com/office/powerpoint/2010/main" val="1559811958"/>
       </p:ext>
     </p:extLst>
   </p:cSld>
@@ -3283,7 +2817,7 @@
                 <a:ea typeface="Helvetica Neue"/>
                 <a:cs typeface="Helvetica Neue"/>
               </a:rPr>
-              <a:t>04</a:t>
+              <a:t>05</a:t>
             </a:r>
           </a:p>
         </p:txBody>
@@ -3748,7 +3282,7 @@
                 <a:ea typeface="Helvetica Neue"/>
                 <a:cs typeface="Helvetica Neue"/>
               </a:rPr>
-              <a:t>05</a:t>
+              <a:t>06</a:t>
             </a:r>
           </a:p>
         </p:txBody>
@@ -3805,7 +3339,7 @@
                 <a:ea typeface="Helvetica Neue"/>
                 <a:cs typeface="Helvetica Neue"/>
               </a:rPr>
-              <a:t>133 passing tests</a:t>
+              <a:t>145 passing tests</a:t>
             </a:r>
           </a:p>
         </p:txBody>
@@ -3919,7 +3453,7 @@
                 <a:ea typeface="Helvetica Neue"/>
                 <a:cs typeface="Helvetica Neue"/>
               </a:rPr>
-              <a:t>Real source and OpenRouter checks</a:t>
+              <a:t>Real sources, two-model fallback, OpenRouter checks</a:t>
             </a:r>
           </a:p>
         </p:txBody>
@@ -4119,7 +3653,7 @@
                 <a:ea typeface="Helvetica Neue"/>
                 <a:cs typeface="Helvetica Neue"/>
               </a:rPr>
-              <a:t>06</a:t>
+              <a:t>07</a:t>
             </a:r>
           </a:p>
         </p:txBody>
@@ -4587,6 +4121,1229 @@
       </p:ext>
     </p:extLst>
   </p:cSld>
+</p:sld>
+</file>
+
+<file path=ppt/slides/slide7.xml><?xml version="1.0" encoding="utf-8"?>
+<p:sld xmlns:a="http://schemas.openxmlformats.org/drawingml/2006/main" xmlns:p="http://schemas.openxmlformats.org/presentationml/2006/main" xmlns:r="http://schemas.openxmlformats.org/officeDocument/2006/relationships">
+  <p:cSld>
+    <p:spTree>
+      <p:nvGrpSpPr>
+        <p:cNvPr id="1" name=""/>
+        <p:cNvGrpSpPr/>
+        <p:nvPr/>
+      </p:nvGrpSpPr>
+      <p:grpSpPr/>
+      <p:sp>
+        <p:nvSpPr>
+          <p:cNvPr id="15" name="">
+            <a:extLst>
+              <a:ext uri="{FF2B5EF4-FFF2-40B4-BE49-F238E27FC236}">
+                <a16:creationId xmlns:a16="http://schemas.microsoft.com/office/drawing/2014/main" id="{CC554AB8-5559-4AA4-BF75-B96A84B91961}"/>
+              </a:ext>
+            </a:extLst>
+          </p:cNvPr>
+          <p:cNvSpPr>
+            <a:spLocks noGrp="1"/>
+          </p:cNvSpPr>
+          <p:nvPr/>
+        </p:nvSpPr>
+        <p:spPr>
+          <a:xfrm>
+            <a:off x="723900" y="590550"/>
+            <a:ext cx="10744200" cy="819150"/>
+          </a:xfrm>
+          <a:prstGeom prst="rect">
+            <a:avLst/>
+          </a:prstGeom>
+          <a:noFill/>
+          <a:ln w="0">
+            <a:noFill/>
+          </a:ln>
+        </p:spPr>
+        <p:txBody>
+          <a:bodyPr>
+            <a:noAutofit/>
+          </a:bodyPr>
+          <a:lstStyle/>
+          <a:p>
+            <a:pPr>
+              <a:defRPr sz="3450" b="1">
+                <a:solidFill>
+                  <a:srgbClr val="172B4D"/>
+                </a:solidFill>
+                <a:latin typeface="Helvetica Neue"/>
+                <a:ea typeface="Helvetica Neue"/>
+                <a:cs typeface="Helvetica Neue"/>
+              </a:defRPr>
+            </a:pPr>
+            <a:r>
+              <a:rPr sz="3450" b="1">
+                <a:solidFill>
+                  <a:srgbClr val="172B4D"/>
+                </a:solidFill>
+                <a:latin typeface="Helvetica Neue"/>
+                <a:ea typeface="Helvetica Neue"/>
+                <a:cs typeface="Helvetica Neue"/>
+              </a:rPr>
+              <a:t>The complete flow</a:t>
+            </a:r>
+          </a:p>
+        </p:txBody>
+      </p:sp>
+      <p:sp>
+        <p:nvSpPr>
+          <p:cNvPr id="2" name="">
+            <a:extLst>
+              <a:ext uri="{FF2B5EF4-FFF2-40B4-BE49-F238E27FC236}">
+                <a16:creationId xmlns:a16="http://schemas.microsoft.com/office/drawing/2014/main" id="{861F0F0A-91DE-4188-BE5F-9B6C761BD426}"/>
+              </a:ext>
+            </a:extLst>
+          </p:cNvPr>
+          <p:cNvSpPr>
+            <a:spLocks noGrp="1"/>
+          </p:cNvSpPr>
+          <p:nvPr/>
+        </p:nvSpPr>
+        <p:spPr>
+          <a:xfrm>
+            <a:off x="10953750" y="6238875"/>
+            <a:ext cx="571500" cy="285750"/>
+          </a:xfrm>
+          <a:prstGeom prst="rect">
+            <a:avLst/>
+          </a:prstGeom>
+          <a:noFill/>
+          <a:ln w="0">
+            <a:noFill/>
+          </a:ln>
+        </p:spPr>
+        <p:txBody>
+          <a:bodyPr>
+            <a:noAutofit/>
+          </a:bodyPr>
+          <a:lstStyle/>
+          <a:p>
+            <a:pPr>
+              <a:defRPr sz="1500" b="0">
+                <a:solidFill>
+                  <a:srgbClr val="526176"/>
+                </a:solidFill>
+                <a:latin typeface="Helvetica Neue"/>
+                <a:ea typeface="Helvetica Neue"/>
+                <a:cs typeface="Helvetica Neue"/>
+              </a:defRPr>
+            </a:pPr>
+            <a:r>
+              <a:rPr sz="1500" b="0">
+                <a:solidFill>
+                  <a:srgbClr val="526176"/>
+                </a:solidFill>
+                <a:latin typeface="Helvetica Neue"/>
+                <a:ea typeface="Helvetica Neue"/>
+                <a:cs typeface="Helvetica Neue"/>
+              </a:rPr>
+              <a:t>02</a:t>
+            </a:r>
+          </a:p>
+        </p:txBody>
+      </p:sp>
+      <p:pic>
+        <p:nvPicPr>
+          <p:cNvPr id="16" name="Picture 15" descr="pr-news-monitor-flow.jpg"/>
+          <p:cNvPicPr>
+            <a:picLocks noChangeAspect="1"/>
+          </p:cNvPicPr>
+          <p:nvPr/>
+        </p:nvPicPr>
+        <p:blipFill>
+          <a:blip r:embed="rId2"/>
+          <a:stretch>
+            <a:fillRect/>
+          </a:stretch>
+        </p:blipFill>
+        <p:spPr>
+          <a:xfrm>
+            <a:off x="722376" y="1645920"/>
+            <a:ext cx="6949440" cy="6787985"/>
+          </a:xfrm>
+          <a:prstGeom prst="rect">
+            <a:avLst/>
+          </a:prstGeom>
+        </p:spPr>
+      </p:pic>
+      <p:sp>
+        <p:nvSpPr>
+          <p:cNvPr id="17" name="TextBox 16"/>
+          <p:cNvSpPr txBox="1"/>
+          <p:nvPr/>
+        </p:nvSpPr>
+        <p:spPr>
+          <a:xfrm>
+            <a:off x="8138160" y="1645920"/>
+            <a:ext cx="3291840" cy="2286000"/>
+          </a:xfrm>
+          <a:prstGeom prst="rect">
+            <a:avLst/>
+          </a:prstGeom>
+          <a:noFill/>
+        </p:spPr>
+        <p:txBody>
+          <a:bodyPr wrap="square">
+            <a:spAutoFit/>
+          </a:bodyPr>
+          <a:lstStyle/>
+          <a:p>
+            <a:r>
+              <a:rPr sz="2100" b="0">
+                <a:solidFill>
+                  <a:srgbClr val="526176"/>
+                </a:solidFill>
+                <a:latin typeface="Helvetica Neue"/>
+              </a:rPr>
+              <a:t>From monitoring scope to evidence-backed feeds. The industry feed reuses the same saved articles and analysis flow.</a:t>
+            </a:r>
+          </a:p>
+        </p:txBody>
+      </p:sp>
+    </p:spTree>
+  </p:cSld>
+  <p:clrMapOvr>
+    <a:masterClrMapping/>
+  </p:clrMapOvr>
+</p:sld>
+</file>
+
+<file path=ppt/slides/slide8.xml><?xml version="1.0" encoding="utf-8"?>
+<p:sld xmlns:a="http://schemas.openxmlformats.org/drawingml/2006/main" xmlns:p="http://schemas.openxmlformats.org/presentationml/2006/main" xmlns:r="http://schemas.openxmlformats.org/officeDocument/2006/relationships">
+  <p:cSld>
+    <p:spTree>
+      <p:nvGrpSpPr>
+        <p:cNvPr id="1" name=""/>
+        <p:cNvGrpSpPr/>
+        <p:nvPr/>
+      </p:nvGrpSpPr>
+      <p:grpSpPr/>
+      <p:sp>
+        <p:nvSpPr>
+          <p:cNvPr id="4" name="">
+            <a:extLst>
+              <a:ext uri="{FF2B5EF4-FFF2-40B4-BE49-F238E27FC236}">
+                <a16:creationId xmlns:a16="http://schemas.microsoft.com/office/drawing/2014/main" id="{EE5CAD81-EF00-438B-AE28-8506CF02FD1F}"/>
+              </a:ext>
+            </a:extLst>
+          </p:cNvPr>
+          <p:cNvSpPr>
+            <a:spLocks noGrp="1"/>
+          </p:cNvSpPr>
+          <p:nvPr/>
+        </p:nvSpPr>
+        <p:spPr>
+          <a:xfrm>
+            <a:off x="723900" y="590550"/>
+            <a:ext cx="10744200" cy="819150"/>
+          </a:xfrm>
+          <a:prstGeom prst="rect">
+            <a:avLst/>
+          </a:prstGeom>
+          <a:noFill/>
+          <a:ln w="0">
+            <a:noFill/>
+          </a:ln>
+        </p:spPr>
+        <p:txBody>
+          <a:bodyPr>
+            <a:noAutofit/>
+          </a:bodyPr>
+          <a:lstStyle/>
+          <a:p>
+            <a:pPr>
+              <a:defRPr sz="3450" b="1">
+                <a:solidFill>
+                  <a:srgbClr val="172B4D"/>
+                </a:solidFill>
+                <a:latin typeface="Helvetica Neue"/>
+                <a:ea typeface="Helvetica Neue"/>
+                <a:cs typeface="Helvetica Neue"/>
+              </a:defRPr>
+            </a:pPr>
+            <a:r>
+              <a:rPr sz="3450" b="1">
+                <a:solidFill>
+                  <a:srgbClr val="172B4D"/>
+                </a:solidFill>
+                <a:latin typeface="Helvetica Neue"/>
+                <a:ea typeface="Helvetica Neue"/>
+                <a:cs typeface="Helvetica Neue"/>
+              </a:rPr>
+              <a:t>Prototype now, prod when it earns it</a:t>
+            </a:r>
+          </a:p>
+        </p:txBody>
+      </p:sp>
+      <p:sp>
+        <p:nvSpPr>
+          <p:cNvPr id="2" name="">
+            <a:extLst>
+              <a:ext uri="{FF2B5EF4-FFF2-40B4-BE49-F238E27FC236}">
+                <a16:creationId xmlns:a16="http://schemas.microsoft.com/office/drawing/2014/main" id="{3BDDF276-1FBA-45A4-9ADA-7D77B1DFA4B2}"/>
+              </a:ext>
+            </a:extLst>
+          </p:cNvPr>
+          <p:cNvSpPr>
+            <a:spLocks noGrp="1"/>
+          </p:cNvSpPr>
+          <p:nvPr/>
+        </p:nvSpPr>
+        <p:spPr>
+          <a:xfrm>
+            <a:off x="10953750" y="6238875"/>
+            <a:ext cx="571500" cy="285750"/>
+          </a:xfrm>
+          <a:prstGeom prst="rect">
+            <a:avLst/>
+          </a:prstGeom>
+          <a:noFill/>
+          <a:ln w="0">
+            <a:noFill/>
+          </a:ln>
+        </p:spPr>
+        <p:txBody>
+          <a:bodyPr>
+            <a:noAutofit/>
+          </a:bodyPr>
+          <a:lstStyle/>
+          <a:p>
+            <a:pPr>
+              <a:defRPr sz="1500" b="0">
+                <a:solidFill>
+                  <a:srgbClr val="526176"/>
+                </a:solidFill>
+                <a:latin typeface="Helvetica Neue"/>
+                <a:ea typeface="Helvetica Neue"/>
+                <a:cs typeface="Helvetica Neue"/>
+              </a:defRPr>
+            </a:pPr>
+            <a:r>
+              <a:rPr sz="1500" b="0">
+                <a:solidFill>
+                  <a:srgbClr val="526176"/>
+                </a:solidFill>
+                <a:latin typeface="Helvetica Neue"/>
+                <a:ea typeface="Helvetica Neue"/>
+                <a:cs typeface="Helvetica Neue"/>
+              </a:rPr>
+              <a:t>04</a:t>
+            </a:r>
+          </a:p>
+        </p:txBody>
+      </p:sp>
+      <p:graphicFrame>
+        <p:nvGraphicFramePr>
+          <p:cNvPr id="6" name=""/>
+          <p:cNvGraphicFramePr/>
+          <p:nvPr/>
+        </p:nvGraphicFramePr>
+        <p:xfrm>
+          <a:off x="723900" y="1809750"/>
+          <a:ext cx="10744200" cy="2875788"/>
+        </p:xfrm>
+        <a:graphic>
+          <a:graphicData uri="http://schemas.openxmlformats.org/drawingml/2006/table">
+            <a:tbl>
+              <a:tblPr/>
+              <a:tblGrid>
+                <a:gridCol w="2952750"/>
+                <a:gridCol w="3762375"/>
+                <a:gridCol w="4029075"/>
+              </a:tblGrid>
+              <a:tr h="571500">
+                <a:tc>
+                  <a:txBody>
+                    <a:bodyPr/>
+                    <a:lstStyle/>
+                    <a:p>
+                      <a:r>
+                        <a:rPr sz="1875" b="1">
+                          <a:solidFill>
+                            <a:srgbClr val="172B4D"/>
+                          </a:solidFill>
+                          <a:latin typeface="Helvetica Neue"/>
+                          <a:ea typeface="Helvetica Neue"/>
+                          <a:cs typeface="Helvetica Neue"/>
+                        </a:rPr>
+                        <a:t>Choice</a:t>
+                      </a:r>
+                    </a:p>
+                  </a:txBody>
+                  <a:tcPr marL="91440" marR="91440" marT="45720" marB="45720">
+                    <a:solidFill>
+                      <a:srgbClr val="EAF0F8"/>
+                    </a:solidFill>
+                  </a:tcPr>
+                </a:tc>
+                <a:tc>
+                  <a:txBody>
+                    <a:bodyPr/>
+                    <a:lstStyle/>
+                    <a:p>
+                      <a:r>
+                        <a:rPr sz="1875" b="1">
+                          <a:solidFill>
+                            <a:srgbClr val="526176"/>
+                          </a:solidFill>
+                          <a:latin typeface="Helvetica Neue"/>
+                          <a:ea typeface="Helvetica Neue"/>
+                          <a:cs typeface="Helvetica Neue"/>
+                        </a:rPr>
+                        <a:t>Now</a:t>
+                      </a:r>
+                    </a:p>
+                  </a:txBody>
+                  <a:tcPr marL="91440" marR="91440" marT="45720" marB="45720">
+                    <a:solidFill>
+                      <a:srgbClr val="EAF0F8"/>
+                    </a:solidFill>
+                  </a:tcPr>
+                </a:tc>
+                <a:tc>
+                  <a:txBody>
+                    <a:bodyPr/>
+                    <a:lstStyle/>
+                    <a:p>
+                      <a:r>
+                        <a:rPr sz="1875" b="1">
+                          <a:solidFill>
+                            <a:srgbClr val="526176"/>
+                          </a:solidFill>
+                          <a:latin typeface="Helvetica Neue"/>
+                          <a:ea typeface="Helvetica Neue"/>
+                          <a:cs typeface="Helvetica Neue"/>
+                        </a:rPr>
+                        <a:t>Prod trigger</a:t>
+                      </a:r>
+                    </a:p>
+                  </a:txBody>
+                  <a:tcPr marL="91440" marR="91440" marT="45720" marB="45720">
+                    <a:solidFill>
+                      <a:srgbClr val="EAF0F8"/>
+                    </a:solidFill>
+                  </a:tcPr>
+                </a:tc>
+              </a:tr>
+              <a:tr h="384048">
+                <a:tc>
+                  <a:txBody>
+                    <a:bodyPr/>
+                    <a:lstStyle/>
+                    <a:p>
+                      <a:r>
+                        <a:rPr sz="1950" b="1">
+                          <a:solidFill>
+                            <a:srgbClr val="172B4D"/>
+                          </a:solidFill>
+                          <a:latin typeface="Helvetica Neue"/>
+                          <a:ea typeface="Helvetica Neue"/>
+                          <a:cs typeface="Helvetica Neue"/>
+                        </a:rPr>
+                        <a:t>Streamlit UI</a:t>
+                      </a:r>
+                    </a:p>
+                  </a:txBody>
+                  <a:tcPr marL="91440" marR="91440" marT="45720" marB="45720">
+                    <a:solidFill>
+                      <a:srgbClr val="FFFFFF"/>
+                    </a:solidFill>
+                  </a:tcPr>
+                </a:tc>
+                <a:tc>
+                  <a:txBody>
+                    <a:bodyPr/>
+                    <a:lstStyle/>
+                    <a:p>
+                      <a:r>
+                        <a:rPr sz="1950" b="0">
+                          <a:solidFill>
+                            <a:srgbClr val="526176"/>
+                          </a:solidFill>
+                          <a:latin typeface="Helvetica Neue"/>
+                          <a:ea typeface="Helvetica Neue"/>
+                          <a:cs typeface="Helvetica Neue"/>
+                        </a:rPr>
+                        <a:t>One Python app, sync refresh</a:t>
+                      </a:r>
+                    </a:p>
+                  </a:txBody>
+                  <a:tcPr marL="91440" marR="91440" marT="45720" marB="45720">
+                    <a:solidFill>
+                      <a:srgbClr val="FFFFFF"/>
+                    </a:solidFill>
+                  </a:tcPr>
+                </a:tc>
+                <a:tc>
+                  <a:txBody>
+                    <a:bodyPr/>
+                    <a:lstStyle/>
+                    <a:p>
+                      <a:r>
+                        <a:rPr sz="1950" b="0">
+                          <a:solidFill>
+                            <a:srgbClr val="526176"/>
+                          </a:solidFill>
+                          <a:latin typeface="Helvetica Neue"/>
+                          <a:ea typeface="Helvetica Neue"/>
+                          <a:cs typeface="Helvetica Neue"/>
+                        </a:rPr>
+                        <a:t>FastAPI + frontend for other clients</a:t>
+                      </a:r>
+                    </a:p>
+                  </a:txBody>
+                  <a:tcPr marL="91440" marR="91440" marT="45720" marB="45720">
+                    <a:solidFill>
+                      <a:srgbClr val="FFFFFF"/>
+                    </a:solidFill>
+                  </a:tcPr>
+                </a:tc>
+              </a:tr>
+              <a:tr h="384048">
+                <a:tc>
+                  <a:txBody>
+                    <a:bodyPr/>
+                    <a:lstStyle/>
+                    <a:p>
+                      <a:r>
+                        <a:rPr sz="1950" b="1">
+                          <a:solidFill>
+                            <a:srgbClr val="172B4D"/>
+                          </a:solidFill>
+                          <a:latin typeface="Helvetica Neue"/>
+                          <a:ea typeface="Helvetica Neue"/>
+                          <a:cs typeface="Helvetica Neue"/>
+                        </a:rPr>
+                        <a:t>SQLite + lock</a:t>
+                      </a:r>
+                    </a:p>
+                  </a:txBody>
+                  <a:tcPr marL="91440" marR="91440" marT="45720" marB="45720">
+                    <a:solidFill>
+                      <a:srgbClr val="FFFFFF"/>
+                    </a:solidFill>
+                  </a:tcPr>
+                </a:tc>
+                <a:tc>
+                  <a:txBody>
+                    <a:bodyPr/>
+                    <a:lstStyle/>
+                    <a:p>
+                      <a:r>
+                        <a:rPr sz="1950" b="0">
+                          <a:solidFill>
+                            <a:srgbClr val="526176"/>
+                          </a:solidFill>
+                          <a:latin typeface="Helvetica Neue"/>
+                          <a:ea typeface="Helvetica Neue"/>
+                          <a:cs typeface="Helvetica Neue"/>
+                        </a:rPr>
+                        <a:t>Durable, no service, one process</a:t>
+                      </a:r>
+                    </a:p>
+                  </a:txBody>
+                  <a:tcPr marL="91440" marR="91440" marT="45720" marB="45720">
+                    <a:solidFill>
+                      <a:srgbClr val="FFFFFF"/>
+                    </a:solidFill>
+                  </a:tcPr>
+                </a:tc>
+                <a:tc>
+                  <a:txBody>
+                    <a:bodyPr/>
+                    <a:lstStyle/>
+                    <a:p>
+                      <a:r>
+                        <a:rPr sz="1950" b="0">
+                          <a:solidFill>
+                            <a:srgbClr val="526176"/>
+                          </a:solidFill>
+                          <a:latin typeface="Helvetica Neue"/>
+                          <a:ea typeface="Helvetica Neue"/>
+                          <a:cs typeface="Helvetica Neue"/>
+                        </a:rPr>
+                        <a:t>Postgres + queued jobs + shared lock</a:t>
+                      </a:r>
+                    </a:p>
+                  </a:txBody>
+                  <a:tcPr marL="91440" marR="91440" marT="45720" marB="45720">
+                    <a:solidFill>
+                      <a:srgbClr val="FFFFFF"/>
+                    </a:solidFill>
+                  </a:tcPr>
+                </a:tc>
+              </a:tr>
+              <a:tr h="384048">
+                <a:tc>
+                  <a:txBody>
+                    <a:bodyPr/>
+                    <a:lstStyle/>
+                    <a:p>
+                      <a:r>
+                        <a:rPr sz="1950" b="1">
+                          <a:solidFill>
+                            <a:srgbClr val="172B4D"/>
+                          </a:solidFill>
+                          <a:latin typeface="Helvetica Neue"/>
+                          <a:ea typeface="Helvetica Neue"/>
+                          <a:cs typeface="Helvetica Neue"/>
+                        </a:rPr>
+                        <a:t>TF-IDF grouping</a:t>
+                      </a:r>
+                    </a:p>
+                  </a:txBody>
+                  <a:tcPr marL="91440" marR="91440" marT="45720" marB="45720">
+                    <a:solidFill>
+                      <a:srgbClr val="FFFFFF"/>
+                    </a:solidFill>
+                  </a:tcPr>
+                </a:tc>
+                <a:tc>
+                  <a:txBody>
+                    <a:bodyPr/>
+                    <a:lstStyle/>
+                    <a:p>
+                      <a:r>
+                        <a:rPr sz="1950" b="0">
+                          <a:solidFill>
+                            <a:srgbClr val="526176"/>
+                          </a:solidFill>
+                          <a:latin typeface="Helvetica Neue"/>
+                          <a:ea typeface="Helvetica Neue"/>
+                          <a:cs typeface="Helvetica Neue"/>
+                        </a:rPr>
+                        <a:t>Cheap, deterministic</a:t>
+                      </a:r>
+                    </a:p>
+                  </a:txBody>
+                  <a:tcPr marL="91440" marR="91440" marT="45720" marB="45720">
+                    <a:solidFill>
+                      <a:srgbClr val="FFFFFF"/>
+                    </a:solidFill>
+                  </a:tcPr>
+                </a:tc>
+                <a:tc>
+                  <a:txBody>
+                    <a:bodyPr/>
+                    <a:lstStyle/>
+                    <a:p>
+                      <a:r>
+                        <a:rPr sz="1950" b="0">
+                          <a:solidFill>
+                            <a:srgbClr val="526176"/>
+                          </a:solidFill>
+                          <a:latin typeface="Helvetica Neue"/>
+                          <a:ea typeface="Helvetica Neue"/>
+                          <a:cs typeface="Helvetica Neue"/>
+                        </a:rPr>
+                        <a:t>Embeddings verifier if eval proves misses</a:t>
+                      </a:r>
+                    </a:p>
+                  </a:txBody>
+                  <a:tcPr marL="91440" marR="91440" marT="45720" marB="45720">
+                    <a:solidFill>
+                      <a:srgbClr val="FFFFFF"/>
+                    </a:solidFill>
+                  </a:tcPr>
+                </a:tc>
+              </a:tr>
+              <a:tr h="384048">
+                <a:tc>
+                  <a:txBody>
+                    <a:bodyPr/>
+                    <a:lstStyle/>
+                    <a:p>
+                      <a:r>
+                        <a:rPr sz="1950" b="1">
+                          <a:solidFill>
+                            <a:srgbClr val="172B4D"/>
+                          </a:solidFill>
+                          <a:latin typeface="Helvetica Neue"/>
+                          <a:ea typeface="Helvetica Neue"/>
+                          <a:cs typeface="Helvetica Neue"/>
+                        </a:rPr>
+                        <a:t>Mini + fallback LLM</a:t>
+                      </a:r>
+                    </a:p>
+                  </a:txBody>
+                  <a:tcPr marL="91440" marR="91440" marT="45720" marB="45720">
+                    <a:solidFill>
+                      <a:srgbClr val="FFFFFF"/>
+                    </a:solidFill>
+                  </a:tcPr>
+                </a:tc>
+                <a:tc>
+                  <a:txBody>
+                    <a:bodyPr/>
+                    <a:lstStyle/>
+                    <a:p>
+                      <a:r>
+                        <a:rPr sz="1950" b="0">
+                          <a:solidFill>
+                            <a:srgbClr val="526176"/>
+                          </a:solidFill>
+                          <a:latin typeface="Helvetica Neue"/>
+                          <a:ea typeface="Helvetica Neue"/>
+                          <a:cs typeface="Helvetica Neue"/>
+                        </a:rPr>
+                        <a:t>Second model, strict schema</a:t>
+                      </a:r>
+                    </a:p>
+                  </a:txBody>
+                  <a:tcPr marL="91440" marR="91440" marT="45720" marB="45720">
+                    <a:solidFill>
+                      <a:srgbClr val="FFFFFF"/>
+                    </a:solidFill>
+                  </a:tcPr>
+                </a:tc>
+                <a:tc>
+                  <a:txBody>
+                    <a:bodyPr/>
+                    <a:lstStyle/>
+                    <a:p>
+                      <a:r>
+                        <a:rPr sz="1950" b="0">
+                          <a:solidFill>
+                            <a:srgbClr val="526176"/>
+                          </a:solidFill>
+                          <a:latin typeface="Helvetica Neue"/>
+                          <a:ea typeface="Helvetica Neue"/>
+                          <a:cs typeface="Helvetica Neue"/>
+                        </a:rPr>
+                        <a:t>Re-pick from measured quality and cost</a:t>
+                      </a:r>
+                    </a:p>
+                  </a:txBody>
+                  <a:tcPr marL="91440" marR="91440" marT="45720" marB="45720">
+                    <a:solidFill>
+                      <a:srgbClr val="FFFFFF"/>
+                    </a:solidFill>
+                  </a:tcPr>
+                </a:tc>
+              </a:tr>
+              <a:tr h="384048">
+                <a:tc>
+                  <a:txBody>
+                    <a:bodyPr/>
+                    <a:lstStyle/>
+                    <a:p>
+                      <a:r>
+                        <a:rPr sz="1950" b="1">
+                          <a:solidFill>
+                            <a:srgbClr val="172B4D"/>
+                          </a:solidFill>
+                          <a:latin typeface="Helvetica Neue"/>
+                          <a:ea typeface="Helvetica Neue"/>
+                          <a:cs typeface="Helvetica Neue"/>
+                        </a:rPr>
+                        <a:t>YAML config</a:t>
+                      </a:r>
+                    </a:p>
+                  </a:txBody>
+                  <a:tcPr marL="91440" marR="91440" marT="45720" marB="45720">
+                    <a:solidFill>
+                      <a:srgbClr val="FFFFFF"/>
+                    </a:solidFill>
+                  </a:tcPr>
+                </a:tc>
+                <a:tc>
+                  <a:txBody>
+                    <a:bodyPr/>
+                    <a:lstStyle/>
+                    <a:p>
+                      <a:r>
+                        <a:rPr sz="1950" b="0">
+                          <a:solidFill>
+                            <a:srgbClr val="526176"/>
+                          </a:solidFill>
+                          <a:latin typeface="Helvetica Neue"/>
+                          <a:ea typeface="Helvetica Neue"/>
+                          <a:cs typeface="Helvetica Neue"/>
+                        </a:rPr>
+                        <a:t>Reviewable in git</a:t>
+                      </a:r>
+                    </a:p>
+                  </a:txBody>
+                  <a:tcPr marL="91440" marR="91440" marT="45720" marB="45720">
+                    <a:solidFill>
+                      <a:srgbClr val="FFFFFF"/>
+                    </a:solidFill>
+                  </a:tcPr>
+                </a:tc>
+                <a:tc>
+                  <a:txBody>
+                    <a:bodyPr/>
+                    <a:lstStyle/>
+                    <a:p>
+                      <a:r>
+                        <a:rPr sz="1950" b="0">
+                          <a:solidFill>
+                            <a:srgbClr val="526176"/>
+                          </a:solidFill>
+                          <a:latin typeface="Helvetica Neue"/>
+                          <a:ea typeface="Helvetica Neue"/>
+                          <a:cs typeface="Helvetica Neue"/>
+                        </a:rPr>
+                        <a:t>Settings UI for non-technical editors</a:t>
+                      </a:r>
+                    </a:p>
+                  </a:txBody>
+                  <a:tcPr marL="91440" marR="91440" marT="45720" marB="45720">
+                    <a:solidFill>
+                      <a:srgbClr val="FFFFFF"/>
+                    </a:solidFill>
+                  </a:tcPr>
+                </a:tc>
+              </a:tr>
+              <a:tr h="384048">
+                <a:tc>
+                  <a:txBody>
+                    <a:bodyPr/>
+                    <a:lstStyle/>
+                    <a:p>
+                      <a:r>
+                        <a:rPr sz="1950" b="1">
+                          <a:solidFill>
+                            <a:srgbClr val="172B4D"/>
+                          </a:solidFill>
+                          <a:latin typeface="Helvetica Neue"/>
+                          <a:ea typeface="Helvetica Neue"/>
+                          <a:cs typeface="Helvetica Neue"/>
+                        </a:rPr>
+                        <a:t>One container</a:t>
+                      </a:r>
+                    </a:p>
+                  </a:txBody>
+                  <a:tcPr marL="91440" marR="91440" marT="45720" marB="45720">
+                    <a:solidFill>
+                      <a:srgbClr val="FFFFFF"/>
+                    </a:solidFill>
+                  </a:tcPr>
+                </a:tc>
+                <a:tc>
+                  <a:txBody>
+                    <a:bodyPr/>
+                    <a:lstStyle/>
+                    <a:p>
+                      <a:r>
+                        <a:rPr sz="1950" b="0">
+                          <a:solidFill>
+                            <a:srgbClr val="526176"/>
+                          </a:solidFill>
+                          <a:latin typeface="Helvetica Neue"/>
+                          <a:ea typeface="Helvetica Neue"/>
+                          <a:cs typeface="Helvetica Neue"/>
+                        </a:rPr>
+                        <a:t>Docker + named volume</a:t>
+                      </a:r>
+                    </a:p>
+                  </a:txBody>
+                  <a:tcPr marL="91440" marR="91440" marT="45720" marB="45720">
+                    <a:solidFill>
+                      <a:srgbClr val="FFFFFF"/>
+                    </a:solidFill>
+                  </a:tcPr>
+                </a:tc>
+                <a:tc>
+                  <a:txBody>
+                    <a:bodyPr/>
+                    <a:lstStyle/>
+                    <a:p>
+                      <a:r>
+                        <a:rPr sz="1950" b="0">
+                          <a:solidFill>
+                            <a:srgbClr val="526176"/>
+                          </a:solidFill>
+                          <a:latin typeface="Helvetica Neue"/>
+                          <a:ea typeface="Helvetica Neue"/>
+                          <a:cs typeface="Helvetica Neue"/>
+                        </a:rPr>
+                        <a:t>Auth, secrets, backups, alerts first</a:t>
+                      </a:r>
+                    </a:p>
+                  </a:txBody>
+                  <a:tcPr marL="91440" marR="91440" marT="45720" marB="45720">
+                    <a:solidFill>
+                      <a:srgbClr val="FFFFFF"/>
+                    </a:solidFill>
+                  </a:tcPr>
+                </a:tc>
+              </a:tr>
+            </a:tbl>
+          </a:graphicData>
+        </a:graphic>
+      </p:graphicFrame>
+    </p:spTree>
+  </p:cSld>
+  <p:clrMapOvr>
+    <a:masterClrMapping/>
+  </p:clrMapOvr>
+</p:sld>
+</file>
+
+<file path=ppt/slides/slide9.xml><?xml version="1.0" encoding="utf-8"?>
+<p:sld xmlns:a="http://schemas.openxmlformats.org/drawingml/2006/main" xmlns:p="http://schemas.openxmlformats.org/presentationml/2006/main" xmlns:r="http://schemas.openxmlformats.org/officeDocument/2006/relationships">
+  <p:cSld>
+    <p:spTree>
+      <p:nvGrpSpPr>
+        <p:cNvPr id="1" name=""/>
+        <p:cNvGrpSpPr/>
+        <p:nvPr/>
+      </p:nvGrpSpPr>
+      <p:grpSpPr/>
+      <p:sp>
+        <p:nvSpPr>
+          <p:cNvPr id="7" name="">
+            <a:extLst>
+              <a:ext uri="{FF2B5EF4-FFF2-40B4-BE49-F238E27FC236}">
+                <a16:creationId xmlns:a16="http://schemas.microsoft.com/office/drawing/2014/main" id="{DE32CF3E-DE3D-4B31-871C-8DA3D3215B78}"/>
+              </a:ext>
+            </a:extLst>
+          </p:cNvPr>
+          <p:cNvSpPr>
+            <a:spLocks noGrp="1"/>
+          </p:cNvSpPr>
+          <p:nvPr/>
+        </p:nvSpPr>
+        <p:spPr>
+          <a:xfrm>
+            <a:off x="723900" y="590550"/>
+            <a:ext cx="10744200" cy="819150"/>
+          </a:xfrm>
+          <a:prstGeom prst="rect">
+            <a:avLst/>
+          </a:prstGeom>
+          <a:noFill/>
+          <a:ln w="0">
+            <a:noFill/>
+          </a:ln>
+        </p:spPr>
+        <p:txBody>
+          <a:bodyPr>
+            <a:noAutofit/>
+          </a:bodyPr>
+          <a:lstStyle/>
+          <a:p>
+            <a:pPr>
+              <a:defRPr sz="3450" b="1">
+                <a:solidFill>
+                  <a:srgbClr val="172B4D"/>
+                </a:solidFill>
+                <a:latin typeface="Helvetica Neue"/>
+                <a:ea typeface="Helvetica Neue"/>
+                <a:cs typeface="Helvetica Neue"/>
+              </a:defRPr>
+            </a:pPr>
+            <a:r>
+              <a:rPr sz="3450" b="1">
+                <a:solidFill>
+                  <a:srgbClr val="172B4D"/>
+                </a:solidFill>
+                <a:latin typeface="Helvetica Neue"/>
+                <a:ea typeface="Helvetica Neue"/>
+                <a:cs typeface="Helvetica Neue"/>
+              </a:rPr>
+              <a:t>Every number is a budget</a:t>
+            </a:r>
+          </a:p>
+        </p:txBody>
+      </p:sp>
+      <p:sp>
+        <p:nvSpPr>
+          <p:cNvPr id="2" name="">
+            <a:extLst>
+              <a:ext uri="{FF2B5EF4-FFF2-40B4-BE49-F238E27FC236}">
+                <a16:creationId xmlns:a16="http://schemas.microsoft.com/office/drawing/2014/main" id="{2F1360FB-E110-4FB8-ACAE-64822178B993}"/>
+              </a:ext>
+            </a:extLst>
+          </p:cNvPr>
+          <p:cNvSpPr>
+            <a:spLocks noGrp="1"/>
+          </p:cNvSpPr>
+          <p:nvPr/>
+        </p:nvSpPr>
+        <p:spPr>
+          <a:xfrm>
+            <a:off x="10953750" y="6238875"/>
+            <a:ext cx="571500" cy="285750"/>
+          </a:xfrm>
+          <a:prstGeom prst="rect">
+            <a:avLst/>
+          </a:prstGeom>
+          <a:noFill/>
+          <a:ln w="0">
+            <a:noFill/>
+          </a:ln>
+        </p:spPr>
+        <p:txBody>
+          <a:bodyPr>
+            <a:noAutofit/>
+          </a:bodyPr>
+          <a:lstStyle/>
+          <a:p>
+            <a:pPr>
+              <a:defRPr sz="1500" b="0">
+                <a:solidFill>
+                  <a:srgbClr val="526176"/>
+                </a:solidFill>
+                <a:latin typeface="Helvetica Neue"/>
+                <a:ea typeface="Helvetica Neue"/>
+                <a:cs typeface="Helvetica Neue"/>
+              </a:defRPr>
+            </a:pPr>
+            <a:r>
+              <a:rPr sz="1500" b="0">
+                <a:solidFill>
+                  <a:srgbClr val="526176"/>
+                </a:solidFill>
+                <a:latin typeface="Helvetica Neue"/>
+                <a:ea typeface="Helvetica Neue"/>
+                <a:cs typeface="Helvetica Neue"/>
+              </a:rPr>
+              <a:t>08</a:t>
+            </a:r>
+          </a:p>
+        </p:txBody>
+      </p:sp>
+      <p:sp>
+        <p:nvSpPr>
+          <p:cNvPr id="3" name="">
+            <a:extLst>
+              <a:ext uri="{FF2B5EF4-FFF2-40B4-BE49-F238E27FC236}">
+                <a16:creationId xmlns:a16="http://schemas.microsoft.com/office/drawing/2014/main" id="{486DC2B6-0411-4E58-A033-539A7914905A}"/>
+              </a:ext>
+            </a:extLst>
+          </p:cNvPr>
+          <p:cNvSpPr>
+            <a:spLocks noGrp="1"/>
+          </p:cNvSpPr>
+          <p:nvPr/>
+        </p:nvSpPr>
+        <p:spPr>
+          <a:xfrm>
+            <a:off x="723900" y="1809750"/>
+            <a:ext cx="10477500" cy="857250"/>
+          </a:xfrm>
+          <a:prstGeom prst="rect">
+            <a:avLst/>
+          </a:prstGeom>
+          <a:noFill/>
+          <a:ln w="0">
+            <a:noFill/>
+          </a:ln>
+        </p:spPr>
+        <p:txBody>
+          <a:bodyPr>
+            <a:noAutofit/>
+          </a:bodyPr>
+          <a:lstStyle/>
+          <a:p>
+            <a:pPr>
+              <a:defRPr sz="4200" b="1">
+                <a:solidFill>
+                  <a:srgbClr val="2358A5"/>
+                </a:solidFill>
+                <a:latin typeface="Helvetica Neue"/>
+                <a:ea typeface="Helvetica Neue"/>
+                <a:cs typeface="Helvetica Neue"/>
+              </a:defRPr>
+            </a:pPr>
+            <a:r>
+              <a:rPr sz="4200" b="1">
+                <a:solidFill>
+                  <a:srgbClr val="2358A5"/>
+                </a:solidFill>
+                <a:latin typeface="Helvetica Neue"/>
+                <a:ea typeface="Helvetica Neue"/>
+                <a:cs typeface="Helvetica Neue"/>
+              </a:rPr>
+              <a:t>Discover: 25 per source, 7 days, 60-second budgets</a:t>
+            </a:r>
+          </a:p>
+        </p:txBody>
+      </p:sp>
+      <p:sp>
+        <p:nvSpPr>
+          <p:cNvPr id="4" name="">
+            <a:extLst>
+              <a:ext uri="{FF2B5EF4-FFF2-40B4-BE49-F238E27FC236}">
+                <a16:creationId xmlns:a16="http://schemas.microsoft.com/office/drawing/2014/main" id="{24CFF2E7-BD86-49F5-94C2-FA32AF2E5047}"/>
+              </a:ext>
+            </a:extLst>
+          </p:cNvPr>
+          <p:cNvSpPr>
+            <a:spLocks noGrp="1"/>
+          </p:cNvSpPr>
+          <p:nvPr/>
+        </p:nvSpPr>
+        <p:spPr>
+          <a:xfrm>
+            <a:off x="723900" y="2809875"/>
+            <a:ext cx="10477500" cy="619125"/>
+          </a:xfrm>
+          <a:prstGeom prst="rect">
+            <a:avLst/>
+          </a:prstGeom>
+          <a:noFill/>
+          <a:ln w="0">
+            <a:noFill/>
+          </a:ln>
+        </p:spPr>
+        <p:txBody>
+          <a:bodyPr>
+            <a:noAutofit/>
+          </a:bodyPr>
+          <a:lstStyle/>
+          <a:p>
+            <a:pPr>
+              <a:defRPr sz="2250" b="0">
+                <a:solidFill>
+                  <a:srgbClr val="526176"/>
+                </a:solidFill>
+                <a:latin typeface="Helvetica Neue"/>
+                <a:ea typeface="Helvetica Neue"/>
+                <a:cs typeface="Helvetica Neue"/>
+              </a:defRPr>
+            </a:pPr>
+            <a:r>
+              <a:rPr sz="2250" b="0">
+                <a:solidFill>
+                  <a:srgbClr val="526176"/>
+                </a:solidFill>
+                <a:latin typeface="Helvetica Neue"/>
+                <a:ea typeface="Helvetica Neue"/>
+                <a:cs typeface="Helvetica Neue"/>
+              </a:rPr>
+              <a:t>Extract: 2 MB pages, 15 seconds, 50-word minimum</a:t>
+            </a:r>
+          </a:p>
+        </p:txBody>
+      </p:sp>
+      <p:sp>
+        <p:nvSpPr>
+          <p:cNvPr id="5" name="">
+            <a:extLst>
+              <a:ext uri="{FF2B5EF4-FFF2-40B4-BE49-F238E27FC236}">
+                <a16:creationId xmlns:a16="http://schemas.microsoft.com/office/drawing/2014/main" id="{9C3E7563-F324-4C2F-9BE0-642AABE8312B}"/>
+              </a:ext>
+            </a:extLst>
+          </p:cNvPr>
+          <p:cNvSpPr>
+            <a:spLocks noGrp="1"/>
+          </p:cNvSpPr>
+          <p:nvPr/>
+        </p:nvSpPr>
+        <p:spPr>
+          <a:xfrm>
+            <a:off x="723900" y="3905250"/>
+            <a:ext cx="10477500" cy="619125"/>
+          </a:xfrm>
+          <a:prstGeom prst="rect">
+            <a:avLst/>
+          </a:prstGeom>
+          <a:noFill/>
+          <a:ln w="0">
+            <a:noFill/>
+          </a:ln>
+        </p:spPr>
+        <p:txBody>
+          <a:bodyPr>
+            <a:noAutofit/>
+          </a:bodyPr>
+          <a:lstStyle/>
+          <a:p>
+            <a:pPr>
+              <a:defRPr sz="2400" b="1">
+                <a:solidFill>
+                  <a:srgbClr val="172B4D"/>
+                </a:solidFill>
+                <a:latin typeface="Helvetica Neue"/>
+                <a:ea typeface="Helvetica Neue"/>
+                <a:cs typeface="Helvetica Neue"/>
+              </a:defRPr>
+            </a:pPr>
+            <a:r>
+              <a:rPr sz="2400" b="1">
+                <a:solidFill>
+                  <a:srgbClr val="172B4D"/>
+                </a:solidFill>
+                <a:latin typeface="Helvetica Neue"/>
+                <a:ea typeface="Helvetica Neue"/>
+                <a:cs typeface="Helvetica Neue"/>
+              </a:rPr>
+              <a:t>Group: 200 articles, 8 per story, 0.42 similarity</a:t>
+            </a:r>
+          </a:p>
+        </p:txBody>
+      </p:sp>
+      <p:sp>
+        <p:nvSpPr>
+          <p:cNvPr id="6" name="">
+            <a:extLst>
+              <a:ext uri="{FF2B5EF4-FFF2-40B4-BE49-F238E27FC236}">
+                <a16:creationId xmlns:a16="http://schemas.microsoft.com/office/drawing/2014/main" id="{D210601C-4288-4936-84E2-2C19F61439A8}"/>
+              </a:ext>
+            </a:extLst>
+          </p:cNvPr>
+          <p:cNvSpPr>
+            <a:spLocks noGrp="1"/>
+          </p:cNvSpPr>
+          <p:nvPr/>
+        </p:nvSpPr>
+        <p:spPr>
+          <a:xfrm>
+            <a:off x="723900" y="4714875"/>
+            <a:ext cx="10477500" cy="762000"/>
+          </a:xfrm>
+          <a:prstGeom prst="rect">
+            <a:avLst/>
+          </a:prstGeom>
+          <a:noFill/>
+          <a:ln w="0">
+            <a:noFill/>
+          </a:ln>
+        </p:spPr>
+        <p:txBody>
+          <a:bodyPr>
+            <a:noAutofit/>
+          </a:bodyPr>
+          <a:lstStyle/>
+          <a:p>
+            <a:pPr>
+              <a:defRPr sz="2250" b="0">
+                <a:solidFill>
+                  <a:srgbClr val="526176"/>
+                </a:solidFill>
+                <a:latin typeface="Helvetica Neue"/>
+                <a:ea typeface="Helvetica Neue"/>
+                <a:cs typeface="Helvetica Neue"/>
+              </a:defRPr>
+            </a:pPr>
+            <a:r>
+              <a:rPr sz="2250" b="0">
+                <a:solidFill>
+                  <a:srgbClr val="526176"/>
+                </a:solidFill>
+                <a:latin typeface="Helvetica Neue"/>
+                <a:ea typeface="Helvetica Neue"/>
+                <a:cs typeface="Helvetica Neue"/>
+              </a:rPr>
+              <a:t>Analyze: 4k chars, 20 calls in 90s, 2 models</a:t>
+            </a:r>
+          </a:p>
+        </p:txBody>
+      </p:sp>
+    </p:spTree>
+  </p:cSld>
+  <p:clrMapOvr>
+    <a:masterClrMapping/>
+  </p:clrMapOvr>
 </p:sld>
 </file>
 

</xml_diff>